<commit_message>
Update Deck Refresh: Vercel-ready build with AI editor, theme editor, and safer secret-key handling
</commit_message>
<xml_diff>
--- a/deck-refresh/sample_files/kpmg_advisory_q4_expected.pptx
+++ b/deck-refresh/sample_files/kpmg_advisory_q4_expected.pptx
@@ -126,14 +126,19 @@
           <a:lstStyle/>
           <a:p>
             <a:pPr>
-              <a:defRPr sz="1300" b="1">
+              <a:defRPr sz="2200" b="1">
                 <a:solidFill>
-                  <a:srgbClr val="00338D"/>
+                  <a:srgbClr val="111827"/>
                 </a:solidFill>
                 <a:latin typeface="Aptos"/>
               </a:defRPr>
             </a:pPr>
             <a:r>
+              <a:rPr sz="2200" b="1">
+                <a:solidFill>
+                  <a:srgbClr val="111827"/>
+                </a:solidFill>
+              </a:rPr>
               <a:t>Q4 Actual vs Q4 Budget</a:t>
             </a:r>
           </a:p>
@@ -280,12 +285,23 @@
         <c:majorTickMark val="out"/>
         <c:minorTickMark val="none"/>
         <c:tickLblPos val="nextTo"/>
+        <c:spPr>
+          <a:ln w="9525">
+            <a:solidFill>
+              <a:srgbClr val="B3B5BA"/>
+            </a:solidFill>
+          </a:ln>
+        </c:spPr>
         <c:txPr>
           <a:bodyPr/>
           <a:lstStyle/>
           <a:p>
             <a:pPr>
-              <a:defRPr sz="800"/>
+              <a:defRPr sz="1000" b="0">
+                <a:solidFill>
+                  <a:srgbClr val="545963"/>
+                </a:solidFill>
+              </a:defRPr>
             </a:pPr>
           </a:p>
         </c:txPr>
@@ -303,9 +319,9 @@
         <c:axPos val="l"/>
         <c:majorGridlines>
           <c:spPr>
-            <a:ln>
+            <a:ln w="9525">
               <a:solidFill>
-                <a:srgbClr val="D8E1EE"/>
+                <a:srgbClr val="D7D8DA"/>
               </a:solidFill>
             </a:ln>
           </c:spPr>
@@ -313,12 +329,23 @@
         <c:majorTickMark val="out"/>
         <c:minorTickMark val="none"/>
         <c:tickLblPos val="nextTo"/>
+        <c:spPr>
+          <a:ln w="9525">
+            <a:solidFill>
+              <a:srgbClr val="B3B5BA"/>
+            </a:solidFill>
+          </a:ln>
+        </c:spPr>
         <c:txPr>
           <a:bodyPr/>
           <a:lstStyle/>
           <a:p>
             <a:pPr>
-              <a:defRPr sz="800"/>
+              <a:defRPr sz="1000" b="0">
+                <a:solidFill>
+                  <a:srgbClr val="545963"/>
+                </a:solidFill>
+              </a:defRPr>
             </a:pPr>
           </a:p>
         </c:txPr>
@@ -334,7 +361,10 @@
         <a:lstStyle/>
         <a:p>
           <a:pPr>
-            <a:defRPr sz="900">
+            <a:defRPr sz="1000" b="0">
+              <a:solidFill>
+                <a:srgbClr val="545963"/>
+              </a:solidFill>
               <a:latin typeface="Aptos"/>
             </a:defRPr>
           </a:pPr>
@@ -370,14 +400,19 @@
           <a:lstStyle/>
           <a:p>
             <a:pPr>
-              <a:defRPr sz="1300" b="1">
+              <a:defRPr sz="2200" b="1">
                 <a:solidFill>
-                  <a:srgbClr val="00338D"/>
+                  <a:srgbClr val="111827"/>
                 </a:solidFill>
                 <a:latin typeface="Aptos"/>
               </a:defRPr>
             </a:pPr>
             <a:r>
+              <a:rPr sz="2200" b="1">
+                <a:solidFill>
+                  <a:srgbClr val="111827"/>
+                </a:solidFill>
+              </a:rPr>
               <a:t>Q4 Service Line Revenue</a:t>
             </a:r>
           </a:p>
@@ -536,12 +571,23 @@
         <c:majorTickMark val="out"/>
         <c:minorTickMark val="none"/>
         <c:tickLblPos val="nextTo"/>
+        <c:spPr>
+          <a:ln w="9525">
+            <a:solidFill>
+              <a:srgbClr val="B3B5BA"/>
+            </a:solidFill>
+          </a:ln>
+        </c:spPr>
         <c:txPr>
           <a:bodyPr/>
           <a:lstStyle/>
           <a:p>
             <a:pPr>
-              <a:defRPr sz="800"/>
+              <a:defRPr sz="1000" b="0">
+                <a:solidFill>
+                  <a:srgbClr val="545963"/>
+                </a:solidFill>
+              </a:defRPr>
             </a:pPr>
           </a:p>
         </c:txPr>
@@ -559,9 +605,9 @@
         <c:axPos val="l"/>
         <c:majorGridlines>
           <c:spPr>
-            <a:ln>
+            <a:ln w="9525">
               <a:solidFill>
-                <a:srgbClr val="D8E1EE"/>
+                <a:srgbClr val="D7D8DA"/>
               </a:solidFill>
             </a:ln>
           </c:spPr>
@@ -569,12 +615,23 @@
         <c:majorTickMark val="out"/>
         <c:minorTickMark val="none"/>
         <c:tickLblPos val="nextTo"/>
+        <c:spPr>
+          <a:ln w="9525">
+            <a:solidFill>
+              <a:srgbClr val="B3B5BA"/>
+            </a:solidFill>
+          </a:ln>
+        </c:spPr>
         <c:txPr>
           <a:bodyPr/>
           <a:lstStyle/>
           <a:p>
             <a:pPr>
-              <a:defRPr sz="800"/>
+              <a:defRPr sz="1000" b="0">
+                <a:solidFill>
+                  <a:srgbClr val="545963"/>
+                </a:solidFill>
+              </a:defRPr>
             </a:pPr>
           </a:p>
         </c:txPr>
@@ -590,7 +647,10 @@
         <a:lstStyle/>
         <a:p>
           <a:pPr>
-            <a:defRPr sz="900">
+            <a:defRPr sz="1000" b="0">
+              <a:solidFill>
+                <a:srgbClr val="545963"/>
+              </a:solidFill>
               <a:latin typeface="Aptos"/>
             </a:defRPr>
           </a:pPr>
@@ -626,14 +686,19 @@
           <a:lstStyle/>
           <a:p>
             <a:pPr>
-              <a:defRPr sz="1300" b="1">
+              <a:defRPr sz="2200" b="1">
                 <a:solidFill>
-                  <a:srgbClr val="00338D"/>
+                  <a:srgbClr val="111827"/>
                 </a:solidFill>
                 <a:latin typeface="Aptos"/>
               </a:defRPr>
             </a:pPr>
             <a:r>
+              <a:rPr sz="2200" b="1">
+                <a:solidFill>
+                  <a:srgbClr val="111827"/>
+                </a:solidFill>
+              </a:rPr>
               <a:t>Q4 Service Line Margins</a:t>
             </a:r>
           </a:p>
@@ -796,12 +861,23 @@
         <c:majorTickMark val="out"/>
         <c:minorTickMark val="none"/>
         <c:tickLblPos val="nextTo"/>
+        <c:spPr>
+          <a:ln w="9525">
+            <a:solidFill>
+              <a:srgbClr val="B3B5BA"/>
+            </a:solidFill>
+          </a:ln>
+        </c:spPr>
         <c:txPr>
           <a:bodyPr/>
           <a:lstStyle/>
           <a:p>
             <a:pPr>
-              <a:defRPr sz="800"/>
+              <a:defRPr sz="1000" b="0">
+                <a:solidFill>
+                  <a:srgbClr val="545963"/>
+                </a:solidFill>
+              </a:defRPr>
             </a:pPr>
           </a:p>
         </c:txPr>
@@ -819,9 +895,9 @@
         <c:axPos val="l"/>
         <c:majorGridlines>
           <c:spPr>
-            <a:ln>
+            <a:ln w="9525">
               <a:solidFill>
-                <a:srgbClr val="D8E1EE"/>
+                <a:srgbClr val="D7D8DA"/>
               </a:solidFill>
             </a:ln>
           </c:spPr>
@@ -829,12 +905,23 @@
         <c:majorTickMark val="out"/>
         <c:minorTickMark val="none"/>
         <c:tickLblPos val="nextTo"/>
+        <c:spPr>
+          <a:ln w="9525">
+            <a:solidFill>
+              <a:srgbClr val="B3B5BA"/>
+            </a:solidFill>
+          </a:ln>
+        </c:spPr>
         <c:txPr>
           <a:bodyPr/>
           <a:lstStyle/>
           <a:p>
             <a:pPr>
-              <a:defRPr sz="800"/>
+              <a:defRPr sz="1000" b="0">
+                <a:solidFill>
+                  <a:srgbClr val="545963"/>
+                </a:solidFill>
+              </a:defRPr>
             </a:pPr>
           </a:p>
         </c:txPr>
@@ -851,7 +938,10 @@
         <a:lstStyle/>
         <a:p>
           <a:pPr>
-            <a:defRPr sz="900">
+            <a:defRPr sz="1000" b="0">
+              <a:solidFill>
+                <a:srgbClr val="545963"/>
+              </a:solidFill>
               <a:latin typeface="Aptos"/>
             </a:defRPr>
           </a:pPr>
@@ -889,14 +979,19 @@
           <a:lstStyle/>
           <a:p>
             <a:pPr>
-              <a:defRPr sz="1300" b="1">
+              <a:defRPr sz="2200" b="1">
                 <a:solidFill>
-                  <a:srgbClr val="00338D"/>
+                  <a:srgbClr val="111827"/>
                 </a:solidFill>
                 <a:latin typeface="Aptos"/>
               </a:defRPr>
             </a:pPr>
             <a:r>
+              <a:rPr sz="2200" b="1">
+                <a:solidFill>
+                  <a:srgbClr val="111827"/>
+                </a:solidFill>
+              </a:rPr>
               <a:t>Q4 Engagement Funnel</a:t>
             </a:r>
           </a:p>
@@ -1055,12 +1150,23 @@
         <c:majorTickMark val="out"/>
         <c:minorTickMark val="none"/>
         <c:tickLblPos val="nextTo"/>
+        <c:spPr>
+          <a:ln w="9525">
+            <a:solidFill>
+              <a:srgbClr val="B3B5BA"/>
+            </a:solidFill>
+          </a:ln>
+        </c:spPr>
         <c:txPr>
           <a:bodyPr/>
           <a:lstStyle/>
           <a:p>
             <a:pPr>
-              <a:defRPr sz="800"/>
+              <a:defRPr sz="1000" b="0">
+                <a:solidFill>
+                  <a:srgbClr val="545963"/>
+                </a:solidFill>
+              </a:defRPr>
             </a:pPr>
           </a:p>
         </c:txPr>
@@ -1078,9 +1184,9 @@
         <c:axPos val="l"/>
         <c:majorGridlines>
           <c:spPr>
-            <a:ln>
+            <a:ln w="9525">
               <a:solidFill>
-                <a:srgbClr val="D8E1EE"/>
+                <a:srgbClr val="D7D8DA"/>
               </a:solidFill>
             </a:ln>
           </c:spPr>
@@ -1088,12 +1194,23 @@
         <c:majorTickMark val="out"/>
         <c:minorTickMark val="none"/>
         <c:tickLblPos val="nextTo"/>
+        <c:spPr>
+          <a:ln w="9525">
+            <a:solidFill>
+              <a:srgbClr val="B3B5BA"/>
+            </a:solidFill>
+          </a:ln>
+        </c:spPr>
         <c:txPr>
           <a:bodyPr/>
           <a:lstStyle/>
           <a:p>
             <a:pPr>
-              <a:defRPr sz="800"/>
+              <a:defRPr sz="1000" b="0">
+                <a:solidFill>
+                  <a:srgbClr val="545963"/>
+                </a:solidFill>
+              </a:defRPr>
             </a:pPr>
           </a:p>
         </c:txPr>
@@ -1109,7 +1226,10 @@
         <a:lstStyle/>
         <a:p>
           <a:pPr>
-            <a:defRPr sz="900">
+            <a:defRPr sz="1000" b="0">
+              <a:solidFill>
+                <a:srgbClr val="545963"/>
+              </a:solidFill>
               <a:latin typeface="Aptos"/>
             </a:defRPr>
           </a:pPr>
@@ -1145,14 +1265,19 @@
           <a:lstStyle/>
           <a:p>
             <a:pPr>
-              <a:defRPr sz="1300" b="1">
+              <a:defRPr sz="2200" b="1">
                 <a:solidFill>
-                  <a:srgbClr val="00338D"/>
+                  <a:srgbClr val="111827"/>
                 </a:solidFill>
                 <a:latin typeface="Aptos"/>
               </a:defRPr>
             </a:pPr>
             <a:r>
+              <a:rPr sz="2200" b="1">
+                <a:solidFill>
+                  <a:srgbClr val="111827"/>
+                </a:solidFill>
+              </a:rPr>
               <a:t>Q4 Revenue and Contribution</a:t>
             </a:r>
           </a:p>
@@ -1311,12 +1436,23 @@
         <c:majorTickMark val="out"/>
         <c:minorTickMark val="none"/>
         <c:tickLblPos val="nextTo"/>
+        <c:spPr>
+          <a:ln w="9525">
+            <a:solidFill>
+              <a:srgbClr val="B3B5BA"/>
+            </a:solidFill>
+          </a:ln>
+        </c:spPr>
         <c:txPr>
           <a:bodyPr/>
           <a:lstStyle/>
           <a:p>
             <a:pPr>
-              <a:defRPr sz="800"/>
+              <a:defRPr sz="1000" b="0">
+                <a:solidFill>
+                  <a:srgbClr val="545963"/>
+                </a:solidFill>
+              </a:defRPr>
             </a:pPr>
           </a:p>
         </c:txPr>
@@ -1334,9 +1470,9 @@
         <c:axPos val="l"/>
         <c:majorGridlines>
           <c:spPr>
-            <a:ln>
+            <a:ln w="9525">
               <a:solidFill>
-                <a:srgbClr val="D8E1EE"/>
+                <a:srgbClr val="D7D8DA"/>
               </a:solidFill>
             </a:ln>
           </c:spPr>
@@ -1344,12 +1480,23 @@
         <c:majorTickMark val="out"/>
         <c:minorTickMark val="none"/>
         <c:tickLblPos val="nextTo"/>
+        <c:spPr>
+          <a:ln w="9525">
+            <a:solidFill>
+              <a:srgbClr val="B3B5BA"/>
+            </a:solidFill>
+          </a:ln>
+        </c:spPr>
         <c:txPr>
           <a:bodyPr/>
           <a:lstStyle/>
           <a:p>
             <a:pPr>
-              <a:defRPr sz="800"/>
+              <a:defRPr sz="1000" b="0">
+                <a:solidFill>
+                  <a:srgbClr val="545963"/>
+                </a:solidFill>
+              </a:defRPr>
             </a:pPr>
           </a:p>
         </c:txPr>
@@ -1365,7 +1512,10 @@
         <a:lstStyle/>
         <a:p>
           <a:pPr>
-            <a:defRPr sz="900">
+            <a:defRPr sz="1000" b="0">
+              <a:solidFill>
+                <a:srgbClr val="545963"/>
+              </a:solidFill>
               <a:latin typeface="Aptos"/>
             </a:defRPr>
           </a:pPr>
@@ -1401,14 +1551,19 @@
           <a:lstStyle/>
           <a:p>
             <a:pPr>
-              <a:defRPr sz="1300" b="1">
+              <a:defRPr sz="2200" b="1">
                 <a:solidFill>
-                  <a:srgbClr val="00338D"/>
+                  <a:srgbClr val="111827"/>
                 </a:solidFill>
                 <a:latin typeface="Aptos"/>
               </a:defRPr>
             </a:pPr>
             <a:r>
+              <a:rPr sz="2200" b="1">
+                <a:solidFill>
+                  <a:srgbClr val="111827"/>
+                </a:solidFill>
+              </a:rPr>
               <a:t>Q4 Practice Costs</a:t>
             </a:r>
           </a:p>
@@ -1567,12 +1722,23 @@
         <c:majorTickMark val="out"/>
         <c:minorTickMark val="none"/>
         <c:tickLblPos val="nextTo"/>
+        <c:spPr>
+          <a:ln w="9525">
+            <a:solidFill>
+              <a:srgbClr val="B3B5BA"/>
+            </a:solidFill>
+          </a:ln>
+        </c:spPr>
         <c:txPr>
           <a:bodyPr/>
           <a:lstStyle/>
           <a:p>
             <a:pPr>
-              <a:defRPr sz="800"/>
+              <a:defRPr sz="1000" b="0">
+                <a:solidFill>
+                  <a:srgbClr val="545963"/>
+                </a:solidFill>
+              </a:defRPr>
             </a:pPr>
           </a:p>
         </c:txPr>
@@ -1590,9 +1756,9 @@
         <c:axPos val="l"/>
         <c:majorGridlines>
           <c:spPr>
-            <a:ln>
+            <a:ln w="9525">
               <a:solidFill>
-                <a:srgbClr val="D8E1EE"/>
+                <a:srgbClr val="D7D8DA"/>
               </a:solidFill>
             </a:ln>
           </c:spPr>
@@ -1600,12 +1766,23 @@
         <c:majorTickMark val="out"/>
         <c:minorTickMark val="none"/>
         <c:tickLblPos val="nextTo"/>
+        <c:spPr>
+          <a:ln w="9525">
+            <a:solidFill>
+              <a:srgbClr val="B3B5BA"/>
+            </a:solidFill>
+          </a:ln>
+        </c:spPr>
         <c:txPr>
           <a:bodyPr/>
           <a:lstStyle/>
           <a:p>
             <a:pPr>
-              <a:defRPr sz="800"/>
+              <a:defRPr sz="1000" b="0">
+                <a:solidFill>
+                  <a:srgbClr val="545963"/>
+                </a:solidFill>
+              </a:defRPr>
             </a:pPr>
           </a:p>
         </c:txPr>
@@ -1621,7 +1798,10 @@
         <a:lstStyle/>
         <a:p>
           <a:pPr>
-            <a:defRPr sz="900">
+            <a:defRPr sz="1000" b="0">
+              <a:solidFill>
+                <a:srgbClr val="545963"/>
+              </a:solidFill>
               <a:latin typeface="Aptos"/>
             </a:defRPr>
           </a:pPr>
@@ -5726,6 +5906,12 @@
 <file path=ppt/slides/slide3.xml><?xml version="1.0" encoding="utf-8"?>
 <p:sld xmlns:a="http://schemas.openxmlformats.org/drawingml/2006/main" xmlns:p="http://schemas.openxmlformats.org/presentationml/2006/main" xmlns:r="http://schemas.openxmlformats.org/officeDocument/2006/relationships">
   <p:cSld>
+    <p:bg>
+      <p:bgPr>
+        <a:noFill/>
+        <a:effectLst/>
+      </p:bgPr>
+    </p:bg>
     <p:spTree>
       <p:nvGrpSpPr>
         <p:cNvPr id="1" name=""/>
@@ -6384,6 +6570,12 @@
 <file path=ppt/slides/slide4.xml><?xml version="1.0" encoding="utf-8"?>
 <p:sld xmlns:a="http://schemas.openxmlformats.org/drawingml/2006/main" xmlns:p="http://schemas.openxmlformats.org/presentationml/2006/main" xmlns:r="http://schemas.openxmlformats.org/officeDocument/2006/relationships">
   <p:cSld>
+    <p:bg>
+      <p:bgPr>
+        <a:noFill/>
+        <a:effectLst/>
+      </p:bgPr>
+    </p:bg>
     <p:spTree>
       <p:nvGrpSpPr>
         <p:cNvPr id="1" name=""/>
@@ -6968,6 +7160,12 @@
 <file path=ppt/slides/slide5.xml><?xml version="1.0" encoding="utf-8"?>
 <p:sld xmlns:a="http://schemas.openxmlformats.org/drawingml/2006/main" xmlns:p="http://schemas.openxmlformats.org/presentationml/2006/main" xmlns:r="http://schemas.openxmlformats.org/officeDocument/2006/relationships">
   <p:cSld>
+    <p:bg>
+      <p:bgPr>
+        <a:noFill/>
+        <a:effectLst/>
+      </p:bgPr>
+    </p:bg>
     <p:spTree>
       <p:nvGrpSpPr>
         <p:cNvPr id="1" name=""/>
@@ -7552,6 +7750,12 @@
 <file path=ppt/slides/slide6.xml><?xml version="1.0" encoding="utf-8"?>
 <p:sld xmlns:a="http://schemas.openxmlformats.org/drawingml/2006/main" xmlns:p="http://schemas.openxmlformats.org/presentationml/2006/main" xmlns:r="http://schemas.openxmlformats.org/officeDocument/2006/relationships">
   <p:cSld>
+    <p:bg>
+      <p:bgPr>
+        <a:noFill/>
+        <a:effectLst/>
+      </p:bgPr>
+    </p:bg>
     <p:spTree>
       <p:nvGrpSpPr>
         <p:cNvPr id="1" name=""/>
@@ -8713,6 +8917,12 @@
 <file path=ppt/slides/slide7.xml><?xml version="1.0" encoding="utf-8"?>
 <p:sld xmlns:a="http://schemas.openxmlformats.org/drawingml/2006/main" xmlns:p="http://schemas.openxmlformats.org/presentationml/2006/main" xmlns:r="http://schemas.openxmlformats.org/officeDocument/2006/relationships">
   <p:cSld>
+    <p:bg>
+      <p:bgPr>
+        <a:noFill/>
+        <a:effectLst/>
+      </p:bgPr>
+    </p:bg>
     <p:spTree>
       <p:nvGrpSpPr>
         <p:cNvPr id="1" name=""/>
@@ -9418,6 +9628,12 @@
 <file path=ppt/slides/slide8.xml><?xml version="1.0" encoding="utf-8"?>
 <p:sld xmlns:a="http://schemas.openxmlformats.org/drawingml/2006/main" xmlns:p="http://schemas.openxmlformats.org/presentationml/2006/main" xmlns:r="http://schemas.openxmlformats.org/officeDocument/2006/relationships">
   <p:cSld>
+    <p:bg>
+      <p:bgPr>
+        <a:noFill/>
+        <a:effectLst/>
+      </p:bgPr>
+    </p:bg>
     <p:spTree>
       <p:nvGrpSpPr>
         <p:cNvPr id="1" name=""/>

</xml_diff>